<commit_message>
Update poster files (final PDF, PPTX, figures)
Finalize poster assets: add final PDF, rename V5 PPTX to Final, remove outdated V4 PDF, and update V6 PPTX. Also add two large predicted-vs-measured figure PNGs (EC and pH) used in the poster for presentation/release.
</commit_message>
<xml_diff>
--- a/poster/Predictive Modeling of Root-Zone Variables Using Greenhouse Data - Project 14 V6.pptx
+++ b/poster/Predictive Modeling of Root-Zone Variables Using Greenhouse Data - Project 14 V6.pptx
@@ -12450,7 +12450,7 @@
         <p:spPr>
           <a:xfrm>
             <a:off x="1155700" y="5440680"/>
-            <a:ext cx="11059319" cy="1652055"/>
+            <a:ext cx="11059319" cy="2043573"/>
           </a:xfrm>
           <a:prstGeom prst="rect">
             <a:avLst/>
@@ -12479,7 +12479,7 @@
                   </a:schemeClr>
                 </a:solidFill>
               </a:rPr>
-              <a:t>Root-zone pH controls nutrient availability, EC (electrical conductivity) reflects salinity and fertilizer load. Manual lab samples are accurate but sparse, creating blind gaps between measurements. A soft sensor can forecast pH and EC between lab samples, helping growers detect drift earlier and adjust irrigation/fertigation decisions.</a:t>
+              <a:t>Root-zone pH and EC affect nutrient availability, salinity stress, and fertilizer efficiency. In greenhouses, they are typically monitored through accurate but infrequent manual samples, leaving gaps where changes from irrigation, fertigation, climate, and plant uptake may be missed. Predicting pH and EC from greenhouse data can give growers earlier insight, support faster corrections, and improve crop management.</a:t>
             </a:r>
           </a:p>
         </p:txBody>
@@ -12574,7 +12574,7 @@
                   </a:schemeClr>
                 </a:solidFill>
               </a:rPr>
-              <a:t>▪ Predict future root-zone pH and EC from the latest lab measurement, forecasted climate, planned irrigation/fertigation and crop-state data.</a:t>
+              <a:t>▪ Develop a soft sensor that predicts future root-zone pH and EC from the latest measurement, forecasted climate, planned irrigation/fertigation and crop-state data.</a:t>
             </a:r>
           </a:p>
           <a:p>
@@ -16386,7 +16386,7 @@
                   <a:srgbClr val="40512B"/>
                 </a:solidFill>
               </a:rPr>
-              <a:t>Walk-forward validation extracts maximum signal from each label</a:t>
+              <a:t>Modeled t₀ → t₁ intervals with accumulated and history features</a:t>
             </a:r>
           </a:p>
         </p:txBody>
@@ -16449,13 +16449,18 @@
           <a:p>
             <a:pPr algn="ctr"/>
             <a:r>
-              <a:rPr lang="en-US" sz="2000" b="1" dirty="0">
+              <a:rPr lang="en-US" sz="3200" b="1" dirty="0">
                 <a:solidFill>
                   <a:srgbClr val="E4AD1F"/>
                 </a:solidFill>
               </a:rPr>
               <a:t>→</a:t>
             </a:r>
+            <a:endParaRPr lang="en-US" sz="2800" b="1" dirty="0">
+              <a:solidFill>
+                <a:srgbClr val="E4AD1F"/>
+              </a:solidFill>
+            </a:endParaRPr>
           </a:p>
         </p:txBody>
       </p:sp>
@@ -16519,7 +16524,7 @@
                   <a:srgbClr val="40512B"/>
                 </a:solidFill>
               </a:rPr>
-              <a:t>Micro-climate model supplies continuous inputs between lab samples</a:t>
+              <a:t>Micro-climate model filled greenhouse-condition gaps</a:t>
             </a:r>
           </a:p>
         </p:txBody>
@@ -16553,7 +16558,7 @@
                   <a:srgbClr val="40512B"/>
                 </a:solidFill>
               </a:rPr>
-              <a:t>No continuous ground truth</a:t>
+              <a:t>Missing internal climate inputs</a:t>
             </a:r>
           </a:p>
         </p:txBody>
@@ -16582,7 +16587,7 @@
           <a:p>
             <a:pPr algn="ctr"/>
             <a:r>
-              <a:rPr lang="en-US" sz="2000" b="1" dirty="0">
+              <a:rPr lang="en-US" sz="2800" b="1" dirty="0">
                 <a:solidFill>
                   <a:srgbClr val="E4AD1F"/>
                 </a:solidFill>
@@ -16652,7 +16657,7 @@
                   <a:srgbClr val="40512B"/>
                 </a:solidFill>
               </a:rPr>
-              <a:t>Resampled to a common 10-min grid with interval-aware features</a:t>
+              <a:t>Added time-gap features and window-based aggregations</a:t>
             </a:r>
           </a:p>
         </p:txBody>
@@ -16715,7 +16720,7 @@
           <a:p>
             <a:pPr algn="ctr"/>
             <a:r>
-              <a:rPr lang="en-US" sz="2000" b="1" dirty="0">
+              <a:rPr lang="en-US" sz="2800" b="1" dirty="0">
                 <a:solidFill>
                   <a:srgbClr val="E4AD1F"/>
                 </a:solidFill>
@@ -16774,7 +16779,7 @@
         </p:spPr>
         <p:txBody>
           <a:bodyPr wrap="square" lIns="91440" tIns="0" rIns="91440" bIns="0" rtlCol="0" anchor="ctr">
-            <a:normAutofit/>
+            <a:normAutofit lnSpcReduction="10000"/>
           </a:bodyPr>
           <a:lstStyle/>
           <a:p>
@@ -16785,7 +16790,7 @@
                   <a:srgbClr val="40512B"/>
                 </a:solidFill>
               </a:rPr>
-              <a:t>Flagged as higher-uncertainty rather than over-claimed</a:t>
+              <a:t>Used log-transformed EC change and absolute-error metrics</a:t>
             </a:r>
           </a:p>
         </p:txBody>
@@ -16819,7 +16824,7 @@
                   <a:srgbClr val="40512B"/>
                 </a:solidFill>
               </a:rPr>
-              <a:t>Rare / extreme fertigation cases</a:t>
+              <a:t>Low EC range sensitivity</a:t>
             </a:r>
           </a:p>
         </p:txBody>
@@ -16848,7 +16853,7 @@
           <a:p>
             <a:pPr algn="ctr"/>
             <a:r>
-              <a:rPr lang="en-US" sz="2000" b="1" dirty="0">
+              <a:rPr lang="en-US" sz="2800" b="1" dirty="0">
                 <a:solidFill>
                   <a:srgbClr val="E4AD1F"/>
                 </a:solidFill>
@@ -16981,7 +16986,7 @@
           <a:p>
             <a:pPr algn="ctr"/>
             <a:r>
-              <a:rPr lang="en-US" sz="2000" b="1" dirty="0">
+              <a:rPr lang="en-US" sz="2800" b="1" dirty="0">
                 <a:solidFill>
                   <a:srgbClr val="E4AD1F"/>
                 </a:solidFill>
@@ -18577,7 +18582,7 @@
                 <a:ea typeface="Cambria" panose="02040503050406030204" pitchFamily="18" charset="0"/>
                 <a:cs typeface="Times New Roman" panose="02020603050405020304" pitchFamily="18" charset="0"/>
               </a:rPr>
-              <a:t>Improves over the last-measurement baseline, supporting earlier pH and EC drift detection.</a:t>
+              <a:t>Improved over the baselines, showing pH/EC dynamics can be learned from greenhouse and crop data.</a:t>
             </a:r>
             <a:endParaRPr lang="he-IL" sz="2400" dirty="0">
               <a:solidFill>
@@ -18674,13 +18679,13 @@
           <a:lstStyle/>
           <a:p>
             <a:r>
-              <a:rPr lang="en-US" sz="2800" b="1">
+              <a:rPr lang="en-US" sz="2800" b="1" dirty="0">
                 <a:solidFill>
                   <a:srgbClr val="557123"/>
                 </a:solidFill>
                 <a:cs typeface="Times New Roman" panose="02020603050405020304" pitchFamily="18" charset="0"/>
               </a:rPr>
-              <a:t>Decision support</a:t>
+              <a:t>Decision support platform</a:t>
             </a:r>
             <a:endParaRPr lang="he-IL" sz="2800" b="1" dirty="0">
               <a:solidFill>
@@ -18727,7 +18732,7 @@
                 <a:ea typeface="Cambria" panose="02040503050406030204" pitchFamily="18" charset="0"/>
                 <a:cs typeface="Times New Roman" panose="02020603050405020304" pitchFamily="18" charset="0"/>
               </a:rPr>
-              <a:t>Forecasts let growers test planned irrigation and fertigation actions before applying them.</a:t>
+              <a:t>Built a user platform where growers upload data and receive future pH/EC predictions.</a:t>
             </a:r>
             <a:endParaRPr lang="he-IL" sz="2400" dirty="0">
               <a:solidFill>

</xml_diff>